<commit_message>
Clean temporary artifacts and finalize benchmark/reporting updates.
Remove leftover extraction test output and ship the latest benchmark/report improvements (character-based sizing, CSV usability, quiz minimum-fill fallback, and UI wording updates) with the current project state.

Made-with: Cursor
</commit_message>
<xml_diff>
--- a/plantilla_universidad.pptx
+++ b/plantilla_universidad.pptx
@@ -22,7 +22,7 @@
       <p:boldItalic r:id="rId8"/>
     </p:embeddedFont>
     <p:embeddedFont>
-      <p:font typeface="Open Sans ExtraBold" panose="020F0502020204030204" pitchFamily="34" charset="0"/>
+      <p:font typeface="Open Sans ExtraBold" panose="020B0906030804020204" pitchFamily="34" charset="0"/>
       <p:bold r:id="rId9"/>
       <p:italic r:id="rId10"/>
       <p:boldItalic r:id="rId11"/>
@@ -5983,7 +5983,7 @@
         </p:nvSpPr>
         <p:spPr>
           <a:xfrm>
-            <a:off x="539" y="3277950"/>
+            <a:off x="600" y="3648225"/>
             <a:ext cx="9143400" cy="188400"/>
           </a:xfrm>
           <a:prstGeom prst="rect">

</xml_diff>